<commit_message>
feat: added python dataclass
</commit_message>
<xml_diff>
--- a/assets/shorts.pptx
+++ b/assets/shorts.pptx
@@ -5,7 +5,7 @@
     <p:sldMasterId id="2147483732" r:id="rId1"/>
   </p:sldMasterIdLst>
   <p:notesMasterIdLst>
-    <p:notesMasterId r:id="rId37"/>
+    <p:notesMasterId r:id="rId38"/>
   </p:notesMasterIdLst>
   <p:sldIdLst>
     <p:sldId id="263" r:id="rId2"/>
@@ -30,19 +30,20 @@
     <p:sldId id="293" r:id="rId21"/>
     <p:sldId id="294" r:id="rId22"/>
     <p:sldId id="306" r:id="rId23"/>
-    <p:sldId id="296" r:id="rId24"/>
-    <p:sldId id="297" r:id="rId25"/>
-    <p:sldId id="298" r:id="rId26"/>
-    <p:sldId id="299" r:id="rId27"/>
-    <p:sldId id="300" r:id="rId28"/>
-    <p:sldId id="301" r:id="rId29"/>
-    <p:sldId id="302" r:id="rId30"/>
-    <p:sldId id="303" r:id="rId31"/>
-    <p:sldId id="304" r:id="rId32"/>
-    <p:sldId id="305" r:id="rId33"/>
-    <p:sldId id="307" r:id="rId34"/>
-    <p:sldId id="308" r:id="rId35"/>
-    <p:sldId id="282" r:id="rId36"/>
+    <p:sldId id="309" r:id="rId24"/>
+    <p:sldId id="296" r:id="rId25"/>
+    <p:sldId id="297" r:id="rId26"/>
+    <p:sldId id="298" r:id="rId27"/>
+    <p:sldId id="299" r:id="rId28"/>
+    <p:sldId id="300" r:id="rId29"/>
+    <p:sldId id="301" r:id="rId30"/>
+    <p:sldId id="302" r:id="rId31"/>
+    <p:sldId id="303" r:id="rId32"/>
+    <p:sldId id="304" r:id="rId33"/>
+    <p:sldId id="305" r:id="rId34"/>
+    <p:sldId id="307" r:id="rId35"/>
+    <p:sldId id="308" r:id="rId36"/>
+    <p:sldId id="282" r:id="rId37"/>
   </p:sldIdLst>
   <p:sldSz cx="10285413" cy="18288000"/>
   <p:notesSz cx="6858000" cy="9144000"/>
@@ -12837,6 +12838,358 @@
   <p:cSld>
     <p:bg>
       <p:bgPr>
+        <a:blipFill>
+          <a:blip r:embed="rId2"/>
+          <a:tile tx="0" ty="0" sx="100000" sy="100000" flip="none" algn="tl"/>
+        </a:blipFill>
+        <a:effectLst/>
+      </p:bgPr>
+    </p:bg>
+    <p:spTree>
+      <p:nvGrpSpPr>
+        <p:cNvPr id="1" name="">
+          <a:extLst>
+            <a:ext uri="{FF2B5EF4-FFF2-40B4-BE49-F238E27FC236}">
+              <a16:creationId xmlns:a16="http://schemas.microsoft.com/office/drawing/2014/main" id="{67B18B78-91D1-FDA0-9CF6-48E4AC8F0038}"/>
+            </a:ext>
+          </a:extLst>
+        </p:cNvPr>
+        <p:cNvGrpSpPr/>
+        <p:nvPr/>
+      </p:nvGrpSpPr>
+      <p:grpSpPr>
+        <a:xfrm>
+          <a:off x="0" y="0"/>
+          <a:ext cx="0" cy="0"/>
+          <a:chOff x="0" y="0"/>
+          <a:chExt cx="0" cy="0"/>
+        </a:xfrm>
+      </p:grpSpPr>
+      <p:sp>
+        <p:nvSpPr>
+          <p:cNvPr id="4" name="TextBox 3">
+            <a:extLst>
+              <a:ext uri="{FF2B5EF4-FFF2-40B4-BE49-F238E27FC236}">
+                <a16:creationId xmlns:a16="http://schemas.microsoft.com/office/drawing/2014/main" id="{7E0ED6F7-32C9-2B97-4246-A7573BB5663E}"/>
+              </a:ext>
+            </a:extLst>
+          </p:cNvPr>
+          <p:cNvSpPr txBox="1"/>
+          <p:nvPr/>
+        </p:nvSpPr>
+        <p:spPr>
+          <a:xfrm>
+            <a:off x="223306" y="4733191"/>
+            <a:ext cx="9838800" cy="1189726"/>
+          </a:xfrm>
+          <a:prstGeom prst="rect">
+            <a:avLst/>
+          </a:prstGeom>
+          <a:gradFill flip="none" rotWithShape="1">
+            <a:gsLst>
+              <a:gs pos="0">
+                <a:schemeClr val="accent2">
+                  <a:lumMod val="67000"/>
+                </a:schemeClr>
+              </a:gs>
+              <a:gs pos="48000">
+                <a:schemeClr val="accent2">
+                  <a:lumMod val="97000"/>
+                  <a:lumOff val="3000"/>
+                </a:schemeClr>
+              </a:gs>
+              <a:gs pos="100000">
+                <a:schemeClr val="accent2">
+                  <a:lumMod val="60000"/>
+                  <a:lumOff val="40000"/>
+                </a:schemeClr>
+              </a:gs>
+            </a:gsLst>
+            <a:lin ang="16200000" scaled="1"/>
+            <a:tileRect/>
+          </a:gradFill>
+          <a:ln>
+            <a:noFill/>
+          </a:ln>
+        </p:spPr>
+        <p:style>
+          <a:lnRef idx="0">
+            <a:scrgbClr r="0" g="0" b="0"/>
+          </a:lnRef>
+          <a:fillRef idx="0">
+            <a:scrgbClr r="0" g="0" b="0"/>
+          </a:fillRef>
+          <a:effectRef idx="0">
+            <a:scrgbClr r="0" g="0" b="0"/>
+          </a:effectRef>
+          <a:fontRef idx="minor">
+            <a:schemeClr val="lt1"/>
+          </a:fontRef>
+        </p:style>
+        <p:txBody>
+          <a:bodyPr wrap="square" rtlCol="0">
+            <a:noAutofit/>
+          </a:bodyPr>
+          <a:lstStyle/>
+          <a:p>
+            <a:pPr marL="0" algn="ctr" defTabSz="457200" rtl="0" eaLnBrk="1" latinLnBrk="0" hangingPunct="1"/>
+            <a:r>
+              <a:rPr lang="en-US" sz="6000" b="1" dirty="0" err="1">
+                <a:ln w="0"/>
+                <a:solidFill>
+                  <a:schemeClr val="tx1"/>
+                </a:solidFill>
+                <a:effectLst>
+                  <a:outerShdw blurRad="38100" dist="19050" dir="2700000" algn="tl" rotWithShape="0">
+                    <a:schemeClr val="dk1">
+                      <a:alpha val="40000"/>
+                    </a:schemeClr>
+                  </a:outerShdw>
+                </a:effectLst>
+                <a:latin typeface="+mj-lt"/>
+              </a:rPr>
+              <a:t>dataclass</a:t>
+            </a:r>
+            <a:endParaRPr lang="en-GB" sz="1600" b="1" dirty="0">
+              <a:ln w="0"/>
+              <a:solidFill>
+                <a:schemeClr val="tx1"/>
+              </a:solidFill>
+              <a:effectLst>
+                <a:outerShdw blurRad="38100" dist="19050" dir="2700000" algn="tl" rotWithShape="0">
+                  <a:schemeClr val="dk1">
+                    <a:alpha val="40000"/>
+                  </a:schemeClr>
+                </a:outerShdw>
+              </a:effectLst>
+              <a:latin typeface="+mj-lt"/>
+            </a:endParaRPr>
+          </a:p>
+        </p:txBody>
+      </p:sp>
+      <p:pic>
+        <p:nvPicPr>
+          <p:cNvPr id="5" name="Picture 4">
+            <a:extLst>
+              <a:ext uri="{FF2B5EF4-FFF2-40B4-BE49-F238E27FC236}">
+                <a16:creationId xmlns:a16="http://schemas.microsoft.com/office/drawing/2014/main" id="{BF001C73-DF35-30E5-356C-0F186FB087E7}"/>
+              </a:ext>
+            </a:extLst>
+          </p:cNvPr>
+          <p:cNvPicPr>
+            <a:picLocks noChangeAspect="1"/>
+          </p:cNvPicPr>
+          <p:nvPr/>
+        </p:nvPicPr>
+        <p:blipFill>
+          <a:blip r:embed="rId3"/>
+          <a:stretch>
+            <a:fillRect/>
+          </a:stretch>
+        </p:blipFill>
+        <p:spPr>
+          <a:xfrm>
+            <a:off x="290127" y="4814930"/>
+            <a:ext cx="1063167" cy="1063167"/>
+          </a:xfrm>
+          <a:prstGeom prst="rect">
+            <a:avLst/>
+          </a:prstGeom>
+        </p:spPr>
+      </p:pic>
+      <p:sp>
+        <p:nvSpPr>
+          <p:cNvPr id="13" name="TextBox 12">
+            <a:extLst>
+              <a:ext uri="{FF2B5EF4-FFF2-40B4-BE49-F238E27FC236}">
+                <a16:creationId xmlns:a16="http://schemas.microsoft.com/office/drawing/2014/main" id="{96F47210-119F-954D-1993-4CF2A6779D96}"/>
+              </a:ext>
+            </a:extLst>
+          </p:cNvPr>
+          <p:cNvSpPr txBox="1"/>
+          <p:nvPr/>
+        </p:nvSpPr>
+        <p:spPr>
+          <a:xfrm>
+            <a:off x="318575" y="11866316"/>
+            <a:ext cx="9648263" cy="1938992"/>
+          </a:xfrm>
+          <a:prstGeom prst="rect">
+            <a:avLst/>
+          </a:prstGeom>
+          <a:noFill/>
+        </p:spPr>
+        <p:txBody>
+          <a:bodyPr wrap="square" rtlCol="0">
+            <a:spAutoFit/>
+          </a:bodyPr>
+          <a:lstStyle/>
+          <a:p>
+            <a:pPr algn="ctr"/>
+            <a:r>
+              <a:rPr lang="en-GB" sz="6000" dirty="0">
+                <a:ln w="0"/>
+                <a:effectLst>
+                  <a:outerShdw blurRad="38100" dist="19050" dir="2700000" algn="tl" rotWithShape="0">
+                    <a:schemeClr val="dk1">
+                      <a:alpha val="40000"/>
+                    </a:schemeClr>
+                  </a:outerShdw>
+                </a:effectLst>
+                <a:latin typeface="Patrick Hand" pitchFamily="2" charset="77"/>
+              </a:rPr>
+              <a:t>Using </a:t>
+            </a:r>
+            <a:r>
+              <a:rPr lang="en-GB" sz="6000" dirty="0" err="1">
+                <a:ln w="0"/>
+                <a:effectLst>
+                  <a:outerShdw blurRad="38100" dist="19050" dir="2700000" algn="tl" rotWithShape="0">
+                    <a:schemeClr val="dk1">
+                      <a:alpha val="40000"/>
+                    </a:schemeClr>
+                  </a:outerShdw>
+                </a:effectLst>
+                <a:latin typeface="Patrick Hand" pitchFamily="2" charset="77"/>
+              </a:rPr>
+              <a:t>dataclass</a:t>
+            </a:r>
+            <a:r>
+              <a:rPr lang="en-GB" sz="6000" dirty="0">
+                <a:ln w="0"/>
+                <a:effectLst>
+                  <a:outerShdw blurRad="38100" dist="19050" dir="2700000" algn="tl" rotWithShape="0">
+                    <a:schemeClr val="dk1">
+                      <a:alpha val="40000"/>
+                    </a:schemeClr>
+                  </a:outerShdw>
+                </a:effectLst>
+                <a:latin typeface="Patrick Hand" pitchFamily="2" charset="77"/>
+              </a:rPr>
+              <a:t> to manage structured data</a:t>
+            </a:r>
+            <a:endParaRPr lang="en-DE" sz="6000" dirty="0">
+              <a:ln w="0"/>
+              <a:effectLst>
+                <a:outerShdw blurRad="38100" dist="19050" dir="2700000" algn="tl" rotWithShape="0">
+                  <a:schemeClr val="dk1">
+                    <a:alpha val="40000"/>
+                  </a:schemeClr>
+                </a:outerShdw>
+              </a:effectLst>
+              <a:latin typeface="Patrick Hand" pitchFamily="2" charset="77"/>
+            </a:endParaRPr>
+          </a:p>
+        </p:txBody>
+      </p:sp>
+      <p:sp>
+        <p:nvSpPr>
+          <p:cNvPr id="25" name="TextBox 24">
+            <a:extLst>
+              <a:ext uri="{FF2B5EF4-FFF2-40B4-BE49-F238E27FC236}">
+                <a16:creationId xmlns:a16="http://schemas.microsoft.com/office/drawing/2014/main" id="{F92902BB-65E3-7B86-4B2A-65C9554F2171}"/>
+              </a:ext>
+            </a:extLst>
+          </p:cNvPr>
+          <p:cNvSpPr txBox="1"/>
+          <p:nvPr/>
+        </p:nvSpPr>
+        <p:spPr>
+          <a:xfrm>
+            <a:off x="-8470937" y="2490606"/>
+            <a:ext cx="5705408" cy="830997"/>
+          </a:xfrm>
+          <a:prstGeom prst="rect">
+            <a:avLst/>
+          </a:prstGeom>
+        </p:spPr>
+        <p:style>
+          <a:lnRef idx="1">
+            <a:schemeClr val="accent2"/>
+          </a:lnRef>
+          <a:fillRef idx="2">
+            <a:schemeClr val="accent2"/>
+          </a:fillRef>
+          <a:effectRef idx="1">
+            <a:schemeClr val="accent2"/>
+          </a:effectRef>
+          <a:fontRef idx="minor">
+            <a:schemeClr val="dk1"/>
+          </a:fontRef>
+        </p:style>
+        <p:txBody>
+          <a:bodyPr wrap="none" rtlCol="0">
+            <a:spAutoFit/>
+          </a:bodyPr>
+          <a:lstStyle/>
+          <a:p>
+            <a:r>
+              <a:rPr lang="en-US" sz="4800" dirty="0">
+                <a:solidFill>
+                  <a:srgbClr val="FF0000"/>
+                </a:solidFill>
+                <a:latin typeface="Patrick Hand" pitchFamily="2" charset="77"/>
+              </a:rPr>
+              <a:t>Image:py_001_dataclass</a:t>
+            </a:r>
+            <a:endParaRPr lang="en-DE" sz="4800" dirty="0">
+              <a:solidFill>
+                <a:srgbClr val="FF0000"/>
+              </a:solidFill>
+              <a:latin typeface="Patrick Hand" pitchFamily="2" charset="77"/>
+            </a:endParaRPr>
+          </a:p>
+        </p:txBody>
+      </p:sp>
+      <p:pic>
+        <p:nvPicPr>
+          <p:cNvPr id="2" name="Picture 1">
+            <a:extLst>
+              <a:ext uri="{FF2B5EF4-FFF2-40B4-BE49-F238E27FC236}">
+                <a16:creationId xmlns:a16="http://schemas.microsoft.com/office/drawing/2014/main" id="{8111D9AD-7775-54B2-F290-E96C7CE6222A}"/>
+              </a:ext>
+            </a:extLst>
+          </p:cNvPr>
+          <p:cNvPicPr>
+            <a:picLocks noChangeAspect="1"/>
+          </p:cNvPicPr>
+          <p:nvPr/>
+        </p:nvPicPr>
+        <p:blipFill rotWithShape="1">
+          <a:blip r:embed="rId4"/>
+          <a:srcRect l="17537" t="25603" r="12337" b="16319"/>
+          <a:stretch>
+            <a:fillRect/>
+          </a:stretch>
+        </p:blipFill>
+        <p:spPr>
+          <a:xfrm>
+            <a:off x="223306" y="6068289"/>
+            <a:ext cx="9838800" cy="5651261"/>
+          </a:xfrm>
+          <a:prstGeom prst="rect">
+            <a:avLst/>
+          </a:prstGeom>
+        </p:spPr>
+      </p:pic>
+    </p:spTree>
+    <p:extLst>
+      <p:ext uri="{BB962C8B-B14F-4D97-AF65-F5344CB8AC3E}">
+        <p14:creationId xmlns:p14="http://schemas.microsoft.com/office/powerpoint/2010/main" val="688552790"/>
+      </p:ext>
+    </p:extLst>
+  </p:cSld>
+  <p:clrMapOvr>
+    <a:masterClrMapping/>
+  </p:clrMapOvr>
+</p:sld>
+</file>
+
+<file path=ppt/slides/slide24.xml><?xml version="1.0" encoding="utf-8"?>
+<p:sld xmlns:a="http://schemas.openxmlformats.org/drawingml/2006/main" xmlns:r="http://schemas.openxmlformats.org/officeDocument/2006/relationships" xmlns:p="http://schemas.openxmlformats.org/presentationml/2006/main">
+  <p:cSld>
+    <p:bg>
+      <p:bgPr>
         <a:gradFill flip="none" rotWithShape="1">
           <a:gsLst>
             <a:gs pos="0">
@@ -13363,7 +13716,7 @@
 </p:sld>
 </file>
 
-<file path=ppt/slides/slide24.xml><?xml version="1.0" encoding="utf-8"?>
+<file path=ppt/slides/slide25.xml><?xml version="1.0" encoding="utf-8"?>
 <p:sld xmlns:a="http://schemas.openxmlformats.org/drawingml/2006/main" xmlns:r="http://schemas.openxmlformats.org/officeDocument/2006/relationships" xmlns:p="http://schemas.openxmlformats.org/presentationml/2006/main">
   <p:cSld>
     <p:bg>
@@ -13868,7 +14221,7 @@
 </p:sld>
 </file>
 
-<file path=ppt/slides/slide25.xml><?xml version="1.0" encoding="utf-8"?>
+<file path=ppt/slides/slide26.xml><?xml version="1.0" encoding="utf-8"?>
 <p:sld xmlns:a="http://schemas.openxmlformats.org/drawingml/2006/main" xmlns:r="http://schemas.openxmlformats.org/officeDocument/2006/relationships" xmlns:p="http://schemas.openxmlformats.org/presentationml/2006/main">
   <p:cSld>
     <p:bg>
@@ -14323,7 +14676,7 @@
 </p:sld>
 </file>
 
-<file path=ppt/slides/slide26.xml><?xml version="1.0" encoding="utf-8"?>
+<file path=ppt/slides/slide27.xml><?xml version="1.0" encoding="utf-8"?>
 <p:sld xmlns:a="http://schemas.openxmlformats.org/drawingml/2006/main" xmlns:r="http://schemas.openxmlformats.org/officeDocument/2006/relationships" xmlns:p="http://schemas.openxmlformats.org/presentationml/2006/main">
   <p:cSld>
     <p:bg>
@@ -14661,7 +15014,7 @@
 </p:sld>
 </file>
 
-<file path=ppt/slides/slide27.xml><?xml version="1.0" encoding="utf-8"?>
+<file path=ppt/slides/slide28.xml><?xml version="1.0" encoding="utf-8"?>
 <p:sld xmlns:a="http://schemas.openxmlformats.org/drawingml/2006/main" xmlns:r="http://schemas.openxmlformats.org/officeDocument/2006/relationships" xmlns:p="http://schemas.openxmlformats.org/presentationml/2006/main">
   <p:cSld>
     <p:bg>
@@ -15041,7 +15394,7 @@
 </p:sld>
 </file>
 
-<file path=ppt/slides/slide28.xml><?xml version="1.0" encoding="utf-8"?>
+<file path=ppt/slides/slide29.xml><?xml version="1.0" encoding="utf-8"?>
 <p:sld xmlns:a="http://schemas.openxmlformats.org/drawingml/2006/main" xmlns:r="http://schemas.openxmlformats.org/officeDocument/2006/relationships" xmlns:p="http://schemas.openxmlformats.org/presentationml/2006/main">
   <p:cSld>
     <p:bg>
@@ -15373,7 +15726,636 @@
 </p:sld>
 </file>
 
-<file path=ppt/slides/slide29.xml><?xml version="1.0" encoding="utf-8"?>
+<file path=ppt/slides/slide3.xml><?xml version="1.0" encoding="utf-8"?>
+<p:sld xmlns:a="http://schemas.openxmlformats.org/drawingml/2006/main" xmlns:r="http://schemas.openxmlformats.org/officeDocument/2006/relationships" xmlns:p="http://schemas.openxmlformats.org/presentationml/2006/main">
+  <p:cSld>
+    <p:bg>
+      <p:bgPr>
+        <a:solidFill>
+          <a:schemeClr val="bg1"/>
+        </a:solidFill>
+        <a:effectLst/>
+      </p:bgPr>
+    </p:bg>
+    <p:spTree>
+      <p:nvGrpSpPr>
+        <p:cNvPr id="1" name="">
+          <a:extLst>
+            <a:ext uri="{FF2B5EF4-FFF2-40B4-BE49-F238E27FC236}">
+              <a16:creationId xmlns:a16="http://schemas.microsoft.com/office/drawing/2014/main" id="{A0DC4AA3-0022-BA0D-9E7D-66B13B5B9A75}"/>
+            </a:ext>
+          </a:extLst>
+        </p:cNvPr>
+        <p:cNvGrpSpPr/>
+        <p:nvPr/>
+      </p:nvGrpSpPr>
+      <p:grpSpPr>
+        <a:xfrm>
+          <a:off x="0" y="0"/>
+          <a:ext cx="0" cy="0"/>
+          <a:chOff x="0" y="0"/>
+          <a:chExt cx="0" cy="0"/>
+        </a:xfrm>
+      </p:grpSpPr>
+      <p:sp>
+        <p:nvSpPr>
+          <p:cNvPr id="2" name="Rectangle 1">
+            <a:extLst>
+              <a:ext uri="{FF2B5EF4-FFF2-40B4-BE49-F238E27FC236}">
+                <a16:creationId xmlns:a16="http://schemas.microsoft.com/office/drawing/2014/main" id="{BB713812-7693-7A33-F95C-E7CBF82C0AC7}"/>
+              </a:ext>
+            </a:extLst>
+          </p:cNvPr>
+          <p:cNvSpPr/>
+          <p:nvPr/>
+        </p:nvSpPr>
+        <p:spPr>
+          <a:xfrm>
+            <a:off x="-795" y="25399"/>
+            <a:ext cx="10285413" cy="9144000"/>
+          </a:xfrm>
+          <a:prstGeom prst="rect">
+            <a:avLst/>
+          </a:prstGeom>
+          <a:gradFill flip="none" rotWithShape="1">
+            <a:gsLst>
+              <a:gs pos="0">
+                <a:srgbClr val="FF0000">
+                  <a:tint val="66000"/>
+                  <a:satMod val="160000"/>
+                </a:srgbClr>
+              </a:gs>
+              <a:gs pos="50000">
+                <a:srgbClr val="FF0000">
+                  <a:tint val="44500"/>
+                  <a:satMod val="160000"/>
+                </a:srgbClr>
+              </a:gs>
+              <a:gs pos="100000">
+                <a:srgbClr val="FF0000">
+                  <a:tint val="23500"/>
+                  <a:satMod val="160000"/>
+                </a:srgbClr>
+              </a:gs>
+            </a:gsLst>
+            <a:lin ang="13500000" scaled="1"/>
+            <a:tileRect/>
+          </a:gradFill>
+          <a:ln w="31750">
+            <a:solidFill>
+              <a:schemeClr val="accent1">
+                <a:shade val="15000"/>
+              </a:schemeClr>
+            </a:solidFill>
+          </a:ln>
+        </p:spPr>
+        <p:style>
+          <a:lnRef idx="2">
+            <a:schemeClr val="accent1">
+              <a:shade val="15000"/>
+            </a:schemeClr>
+          </a:lnRef>
+          <a:fillRef idx="1">
+            <a:schemeClr val="accent1"/>
+          </a:fillRef>
+          <a:effectRef idx="0">
+            <a:schemeClr val="accent1"/>
+          </a:effectRef>
+          <a:fontRef idx="minor">
+            <a:schemeClr val="lt1"/>
+          </a:fontRef>
+        </p:style>
+        <p:txBody>
+          <a:bodyPr rtlCol="0" anchor="ctr"/>
+          <a:lstStyle/>
+          <a:p>
+            <a:pPr marL="0" algn="ctr" defTabSz="457200" rtl="1" eaLnBrk="1" latinLnBrk="0" hangingPunct="1"/>
+            <a:endParaRPr lang="en-DE" dirty="0">
+              <a:latin typeface="Patrick Hand" pitchFamily="2" charset="77"/>
+            </a:endParaRPr>
+          </a:p>
+        </p:txBody>
+      </p:sp>
+      <p:sp>
+        <p:nvSpPr>
+          <p:cNvPr id="5" name="Rectangle 4">
+            <a:extLst>
+              <a:ext uri="{FF2B5EF4-FFF2-40B4-BE49-F238E27FC236}">
+                <a16:creationId xmlns:a16="http://schemas.microsoft.com/office/drawing/2014/main" id="{389978CD-953A-DE5A-0C5E-B22506EFEBA5}"/>
+              </a:ext>
+            </a:extLst>
+          </p:cNvPr>
+          <p:cNvSpPr/>
+          <p:nvPr/>
+        </p:nvSpPr>
+        <p:spPr>
+          <a:xfrm>
+            <a:off x="-794" y="9144000"/>
+            <a:ext cx="10285413" cy="9144000"/>
+          </a:xfrm>
+          <a:prstGeom prst="rect">
+            <a:avLst/>
+          </a:prstGeom>
+          <a:gradFill flip="none" rotWithShape="1">
+            <a:gsLst>
+              <a:gs pos="0">
+                <a:schemeClr val="accent6">
+                  <a:tint val="66000"/>
+                  <a:satMod val="160000"/>
+                </a:schemeClr>
+              </a:gs>
+              <a:gs pos="50000">
+                <a:schemeClr val="accent6">
+                  <a:tint val="44500"/>
+                  <a:satMod val="160000"/>
+                </a:schemeClr>
+              </a:gs>
+              <a:gs pos="100000">
+                <a:schemeClr val="accent6">
+                  <a:tint val="23500"/>
+                  <a:satMod val="160000"/>
+                </a:schemeClr>
+              </a:gs>
+            </a:gsLst>
+            <a:lin ang="13500000" scaled="1"/>
+            <a:tileRect/>
+          </a:gradFill>
+          <a:ln w="31750">
+            <a:solidFill>
+              <a:schemeClr val="accent1">
+                <a:shade val="15000"/>
+              </a:schemeClr>
+            </a:solidFill>
+          </a:ln>
+        </p:spPr>
+        <p:style>
+          <a:lnRef idx="2">
+            <a:schemeClr val="accent1">
+              <a:shade val="15000"/>
+            </a:schemeClr>
+          </a:lnRef>
+          <a:fillRef idx="1">
+            <a:schemeClr val="accent1"/>
+          </a:fillRef>
+          <a:effectRef idx="0">
+            <a:schemeClr val="accent1"/>
+          </a:effectRef>
+          <a:fontRef idx="minor">
+            <a:schemeClr val="lt1"/>
+          </a:fontRef>
+        </p:style>
+        <p:txBody>
+          <a:bodyPr rtlCol="0" anchor="ctr"/>
+          <a:lstStyle/>
+          <a:p>
+            <a:pPr marL="0" algn="ctr" defTabSz="457200" rtl="1" eaLnBrk="1" latinLnBrk="0" hangingPunct="1"/>
+            <a:endParaRPr lang="en-DE" dirty="0">
+              <a:latin typeface="Patrick Hand" pitchFamily="2" charset="77"/>
+            </a:endParaRPr>
+          </a:p>
+        </p:txBody>
+      </p:sp>
+      <p:pic>
+        <p:nvPicPr>
+          <p:cNvPr id="6" name="Picture 5">
+            <a:extLst>
+              <a:ext uri="{FF2B5EF4-FFF2-40B4-BE49-F238E27FC236}">
+                <a16:creationId xmlns:a16="http://schemas.microsoft.com/office/drawing/2014/main" id="{E9CF1C6B-B5DF-DB15-335C-9EF9D02E2644}"/>
+              </a:ext>
+            </a:extLst>
+          </p:cNvPr>
+          <p:cNvPicPr>
+            <a:picLocks noChangeAspect="1"/>
+          </p:cNvPicPr>
+          <p:nvPr/>
+        </p:nvPicPr>
+        <p:blipFill rotWithShape="1">
+          <a:blip r:embed="rId3"/>
+          <a:srcRect l="21500" t="36257" r="12564" b="17086"/>
+          <a:stretch>
+            <a:fillRect/>
+          </a:stretch>
+        </p:blipFill>
+        <p:spPr>
+          <a:xfrm>
+            <a:off x="9333" y="2819400"/>
+            <a:ext cx="10315977" cy="5486400"/>
+          </a:xfrm>
+          <a:prstGeom prst="rect">
+            <a:avLst/>
+          </a:prstGeom>
+        </p:spPr>
+      </p:pic>
+      <p:pic>
+        <p:nvPicPr>
+          <p:cNvPr id="7" name="Picture 6">
+            <a:extLst>
+              <a:ext uri="{FF2B5EF4-FFF2-40B4-BE49-F238E27FC236}">
+                <a16:creationId xmlns:a16="http://schemas.microsoft.com/office/drawing/2014/main" id="{F75C1FB9-F7E4-D807-6D39-929DB29A7EFE}"/>
+              </a:ext>
+            </a:extLst>
+          </p:cNvPr>
+          <p:cNvPicPr>
+            <a:picLocks noChangeAspect="1"/>
+          </p:cNvPicPr>
+          <p:nvPr/>
+        </p:nvPicPr>
+        <p:blipFill rotWithShape="1">
+          <a:blip r:embed="rId4"/>
+          <a:srcRect l="15971" t="42773" r="9579" b="22419"/>
+          <a:stretch>
+            <a:fillRect/>
+          </a:stretch>
+        </p:blipFill>
+        <p:spPr>
+          <a:xfrm>
+            <a:off x="-30564" y="12598400"/>
+            <a:ext cx="10305074" cy="2006600"/>
+          </a:xfrm>
+          <a:prstGeom prst="rect">
+            <a:avLst/>
+          </a:prstGeom>
+        </p:spPr>
+      </p:pic>
+      <p:sp>
+        <p:nvSpPr>
+          <p:cNvPr id="10" name="Rectangle 9">
+            <a:extLst>
+              <a:ext uri="{FF2B5EF4-FFF2-40B4-BE49-F238E27FC236}">
+                <a16:creationId xmlns:a16="http://schemas.microsoft.com/office/drawing/2014/main" id="{F931037C-127C-092B-3046-21C5E1305743}"/>
+              </a:ext>
+            </a:extLst>
+          </p:cNvPr>
+          <p:cNvSpPr/>
+          <p:nvPr/>
+        </p:nvSpPr>
+        <p:spPr>
+          <a:xfrm>
+            <a:off x="1577100" y="981670"/>
+            <a:ext cx="7131212" cy="1323439"/>
+          </a:xfrm>
+          <a:prstGeom prst="rect">
+            <a:avLst/>
+          </a:prstGeom>
+          <a:noFill/>
+          <a:ln>
+            <a:noFill/>
+          </a:ln>
+        </p:spPr>
+        <p:style>
+          <a:lnRef idx="0">
+            <a:scrgbClr r="0" g="0" b="0"/>
+          </a:lnRef>
+          <a:fillRef idx="0">
+            <a:scrgbClr r="0" g="0" b="0"/>
+          </a:fillRef>
+          <a:effectRef idx="0">
+            <a:scrgbClr r="0" g="0" b="0"/>
+          </a:effectRef>
+          <a:fontRef idx="minor">
+            <a:schemeClr val="accent6"/>
+          </a:fontRef>
+        </p:style>
+        <p:txBody>
+          <a:bodyPr wrap="square" lIns="91440" tIns="45720" rIns="91440" bIns="45720">
+            <a:spAutoFit/>
+          </a:bodyPr>
+          <a:lstStyle/>
+          <a:p>
+            <a:pPr algn="ctr"/>
+            <a:r>
+              <a:rPr lang="en-GB" sz="8000" b="1" dirty="0">
+                <a:ln w="6600">
+                  <a:solidFill>
+                    <a:schemeClr val="accent2"/>
+                  </a:solidFill>
+                  <a:prstDash val="solid"/>
+                </a:ln>
+                <a:solidFill>
+                  <a:srgbClr val="FFFFFF"/>
+                </a:solidFill>
+                <a:effectLst>
+                  <a:outerShdw dist="38100" dir="2700000" algn="tl" rotWithShape="0">
+                    <a:schemeClr val="accent2"/>
+                  </a:outerShdw>
+                </a:effectLst>
+                <a:latin typeface="Patrick Hand" pitchFamily="2" charset="77"/>
+              </a:rPr>
+              <a:t>DIRTY CODE</a:t>
+            </a:r>
+          </a:p>
+        </p:txBody>
+      </p:sp>
+      <p:pic>
+        <p:nvPicPr>
+          <p:cNvPr id="12" name="Graphic 11" descr="Close with solid fill">
+            <a:extLst>
+              <a:ext uri="{FF2B5EF4-FFF2-40B4-BE49-F238E27FC236}">
+                <a16:creationId xmlns:a16="http://schemas.microsoft.com/office/drawing/2014/main" id="{28F1D416-1464-F569-BAAC-4CE3AC639CD1}"/>
+              </a:ext>
+            </a:extLst>
+          </p:cNvPr>
+          <p:cNvPicPr>
+            <a:picLocks noChangeAspect="1"/>
+          </p:cNvPicPr>
+          <p:nvPr/>
+        </p:nvPicPr>
+        <p:blipFill>
+          <a:blip r:embed="rId5">
+            <a:extLst>
+              <a:ext uri="{96DAC541-7B7A-43D3-8B79-37D633B846F1}">
+                <asvg:svgBlip xmlns:asvg="http://schemas.microsoft.com/office/drawing/2016/SVG/main" r:embed="rId6"/>
+              </a:ext>
+            </a:extLst>
+          </a:blip>
+          <a:stretch>
+            <a:fillRect/>
+          </a:stretch>
+        </p:blipFill>
+        <p:spPr>
+          <a:xfrm>
+            <a:off x="7678818" y="1219200"/>
+            <a:ext cx="914400" cy="914400"/>
+          </a:xfrm>
+          <a:prstGeom prst="rect">
+            <a:avLst/>
+          </a:prstGeom>
+        </p:spPr>
+      </p:pic>
+      <p:pic>
+        <p:nvPicPr>
+          <p:cNvPr id="14" name="Graphic 13" descr="Tick with solid fill">
+            <a:extLst>
+              <a:ext uri="{FF2B5EF4-FFF2-40B4-BE49-F238E27FC236}">
+                <a16:creationId xmlns:a16="http://schemas.microsoft.com/office/drawing/2014/main" id="{F2663517-508C-9559-F50A-E9F1B59AB837}"/>
+              </a:ext>
+            </a:extLst>
+          </p:cNvPr>
+          <p:cNvPicPr>
+            <a:picLocks noChangeAspect="1"/>
+          </p:cNvPicPr>
+          <p:nvPr/>
+        </p:nvPicPr>
+        <p:blipFill>
+          <a:blip r:embed="rId7">
+            <a:extLst>
+              <a:ext uri="{96DAC541-7B7A-43D3-8B79-37D633B846F1}">
+                <asvg:svgBlip xmlns:asvg="http://schemas.microsoft.com/office/drawing/2016/SVG/main" r:embed="rId8"/>
+              </a:ext>
+            </a:extLst>
+          </a:blip>
+          <a:stretch>
+            <a:fillRect/>
+          </a:stretch>
+        </p:blipFill>
+        <p:spPr>
+          <a:xfrm>
+            <a:off x="7793912" y="10998200"/>
+            <a:ext cx="914400" cy="914400"/>
+          </a:xfrm>
+          <a:prstGeom prst="rect">
+            <a:avLst/>
+          </a:prstGeom>
+        </p:spPr>
+      </p:pic>
+      <p:sp>
+        <p:nvSpPr>
+          <p:cNvPr id="15" name="Rectangle 14">
+            <a:extLst>
+              <a:ext uri="{FF2B5EF4-FFF2-40B4-BE49-F238E27FC236}">
+                <a16:creationId xmlns:a16="http://schemas.microsoft.com/office/drawing/2014/main" id="{3C884966-F1E0-E28C-8306-94E3476AE9EB}"/>
+              </a:ext>
+            </a:extLst>
+          </p:cNvPr>
+          <p:cNvSpPr/>
+          <p:nvPr/>
+        </p:nvSpPr>
+        <p:spPr>
+          <a:xfrm>
+            <a:off x="1462006" y="10805060"/>
+            <a:ext cx="7131212" cy="1323439"/>
+          </a:xfrm>
+          <a:prstGeom prst="rect">
+            <a:avLst/>
+          </a:prstGeom>
+          <a:noFill/>
+          <a:ln>
+            <a:noFill/>
+          </a:ln>
+        </p:spPr>
+        <p:style>
+          <a:lnRef idx="0">
+            <a:scrgbClr r="0" g="0" b="0"/>
+          </a:lnRef>
+          <a:fillRef idx="0">
+            <a:scrgbClr r="0" g="0" b="0"/>
+          </a:fillRef>
+          <a:effectRef idx="0">
+            <a:scrgbClr r="0" g="0" b="0"/>
+          </a:effectRef>
+          <a:fontRef idx="minor">
+            <a:schemeClr val="accent6"/>
+          </a:fontRef>
+        </p:style>
+        <p:txBody>
+          <a:bodyPr wrap="square" lIns="91440" tIns="45720" rIns="91440" bIns="45720">
+            <a:spAutoFit/>
+          </a:bodyPr>
+          <a:lstStyle/>
+          <a:p>
+            <a:pPr algn="ctr"/>
+            <a:r>
+              <a:rPr lang="en-GB" sz="8000" b="1" dirty="0">
+                <a:ln w="12700">
+                  <a:solidFill>
+                    <a:srgbClr val="00B050"/>
+                  </a:solidFill>
+                  <a:prstDash val="solid"/>
+                </a:ln>
+                <a:pattFill prst="pct50">
+                  <a:fgClr>
+                    <a:schemeClr val="accent1"/>
+                  </a:fgClr>
+                  <a:bgClr>
+                    <a:schemeClr val="accent1">
+                      <a:lumMod val="20000"/>
+                      <a:lumOff val="80000"/>
+                    </a:schemeClr>
+                  </a:bgClr>
+                </a:pattFill>
+                <a:effectLst>
+                  <a:outerShdw dist="38100" dir="2640000" algn="bl" rotWithShape="0">
+                    <a:schemeClr val="accent1"/>
+                  </a:outerShdw>
+                </a:effectLst>
+                <a:latin typeface="Patrick Hand" pitchFamily="2" charset="77"/>
+              </a:rPr>
+              <a:t>CLEAN CODE</a:t>
+            </a:r>
+          </a:p>
+        </p:txBody>
+      </p:sp>
+      <p:sp>
+        <p:nvSpPr>
+          <p:cNvPr id="18" name="Down Arrow 17">
+            <a:extLst>
+              <a:ext uri="{FF2B5EF4-FFF2-40B4-BE49-F238E27FC236}">
+                <a16:creationId xmlns:a16="http://schemas.microsoft.com/office/drawing/2014/main" id="{F519B709-69F6-84B3-4A2B-206F2AAA7983}"/>
+              </a:ext>
+            </a:extLst>
+          </p:cNvPr>
+          <p:cNvSpPr/>
+          <p:nvPr/>
+        </p:nvSpPr>
+        <p:spPr>
+          <a:xfrm>
+            <a:off x="3683000" y="8610600"/>
+            <a:ext cx="2921000" cy="2194460"/>
+          </a:xfrm>
+          <a:prstGeom prst="downArrow">
+            <a:avLst/>
+          </a:prstGeom>
+          <a:solidFill>
+            <a:schemeClr val="bg1"/>
+          </a:solidFill>
+          <a:ln w="31750">
+            <a:solidFill>
+              <a:schemeClr val="accent1">
+                <a:shade val="15000"/>
+              </a:schemeClr>
+            </a:solidFill>
+          </a:ln>
+        </p:spPr>
+        <p:style>
+          <a:lnRef idx="2">
+            <a:schemeClr val="accent1">
+              <a:shade val="15000"/>
+            </a:schemeClr>
+          </a:lnRef>
+          <a:fillRef idx="1">
+            <a:schemeClr val="accent1"/>
+          </a:fillRef>
+          <a:effectRef idx="0">
+            <a:schemeClr val="accent1"/>
+          </a:effectRef>
+          <a:fontRef idx="minor">
+            <a:schemeClr val="lt1"/>
+          </a:fontRef>
+        </p:style>
+        <p:txBody>
+          <a:bodyPr rtlCol="0" anchor="ctr"/>
+          <a:lstStyle/>
+          <a:p>
+            <a:pPr marL="0" algn="ctr" defTabSz="457200" rtl="0" eaLnBrk="1" latinLnBrk="0" hangingPunct="1"/>
+            <a:endParaRPr lang="en-DE" dirty="0">
+              <a:latin typeface="Patrick Hand" pitchFamily="2" charset="77"/>
+            </a:endParaRPr>
+          </a:p>
+        </p:txBody>
+      </p:sp>
+      <p:sp>
+        <p:nvSpPr>
+          <p:cNvPr id="3" name="Rectangle 2">
+            <a:extLst>
+              <a:ext uri="{FF2B5EF4-FFF2-40B4-BE49-F238E27FC236}">
+                <a16:creationId xmlns:a16="http://schemas.microsoft.com/office/drawing/2014/main" id="{0A3573D3-02FD-8867-C498-4782AE7F0917}"/>
+              </a:ext>
+            </a:extLst>
+          </p:cNvPr>
+          <p:cNvSpPr/>
+          <p:nvPr/>
+        </p:nvSpPr>
+        <p:spPr>
+          <a:xfrm>
+            <a:off x="-8208470" y="2819400"/>
+            <a:ext cx="7768473" cy="923330"/>
+          </a:xfrm>
+          <a:prstGeom prst="rect">
+            <a:avLst/>
+          </a:prstGeom>
+          <a:ln>
+            <a:solidFill>
+              <a:schemeClr val="tx1"/>
+            </a:solidFill>
+          </a:ln>
+        </p:spPr>
+        <p:style>
+          <a:lnRef idx="1">
+            <a:schemeClr val="accent6"/>
+          </a:lnRef>
+          <a:fillRef idx="2">
+            <a:schemeClr val="accent6"/>
+          </a:fillRef>
+          <a:effectRef idx="1">
+            <a:schemeClr val="accent6"/>
+          </a:effectRef>
+          <a:fontRef idx="minor">
+            <a:schemeClr val="dk1"/>
+          </a:fontRef>
+        </p:style>
+        <p:txBody>
+          <a:bodyPr wrap="none" lIns="91440" tIns="45720" rIns="91440" bIns="45720">
+            <a:spAutoFit/>
+            <a:scene3d>
+              <a:camera prst="orthographicFront"/>
+              <a:lightRig rig="soft" dir="t">
+                <a:rot lat="0" lon="0" rev="15600000"/>
+              </a:lightRig>
+            </a:scene3d>
+            <a:sp3d extrusionH="57150" prstMaterial="softEdge">
+              <a:bevelT w="25400" h="38100"/>
+            </a:sp3d>
+          </a:bodyPr>
+          <a:lstStyle/>
+          <a:p>
+            <a:pPr algn="ctr"/>
+            <a:r>
+              <a:rPr lang="en-GB" sz="5400" dirty="0">
+                <a:ln w="0"/>
+                <a:solidFill>
+                  <a:schemeClr val="tx1"/>
+                </a:solidFill>
+                <a:effectLst>
+                  <a:outerShdw blurRad="38100" dist="19050" dir="2700000" algn="tl" rotWithShape="0">
+                    <a:schemeClr val="dk1">
+                      <a:alpha val="40000"/>
+                    </a:schemeClr>
+                  </a:outerShdw>
+                </a:effectLst>
+                <a:latin typeface="Patrick Hand" pitchFamily="2" charset="77"/>
+              </a:rPr>
+              <a:t>py_002_list_comprehensions</a:t>
+            </a:r>
+            <a:endParaRPr lang="en-DE" sz="5400" dirty="0">
+              <a:ln w="0"/>
+              <a:solidFill>
+                <a:schemeClr val="tx1"/>
+              </a:solidFill>
+              <a:effectLst>
+                <a:outerShdw blurRad="38100" dist="19050" dir="2700000" algn="tl" rotWithShape="0">
+                  <a:schemeClr val="dk1">
+                    <a:alpha val="40000"/>
+                  </a:schemeClr>
+                </a:outerShdw>
+              </a:effectLst>
+            </a:endParaRPr>
+          </a:p>
+        </p:txBody>
+      </p:sp>
+    </p:spTree>
+    <p:extLst>
+      <p:ext uri="{BB962C8B-B14F-4D97-AF65-F5344CB8AC3E}">
+        <p14:creationId xmlns:p14="http://schemas.microsoft.com/office/powerpoint/2010/main" val="1367177939"/>
+      </p:ext>
+    </p:extLst>
+  </p:cSld>
+  <p:clrMapOvr>
+    <a:masterClrMapping/>
+  </p:clrMapOvr>
+</p:sld>
+</file>
+
+<file path=ppt/slides/slide30.xml><?xml version="1.0" encoding="utf-8"?>
 <p:sld xmlns:a="http://schemas.openxmlformats.org/drawingml/2006/main" xmlns:r="http://schemas.openxmlformats.org/officeDocument/2006/relationships" xmlns:p="http://schemas.openxmlformats.org/presentationml/2006/main">
   <p:cSld>
     <p:bg>
@@ -15750,636 +16732,7 @@
 </p:sld>
 </file>
 
-<file path=ppt/slides/slide3.xml><?xml version="1.0" encoding="utf-8"?>
-<p:sld xmlns:a="http://schemas.openxmlformats.org/drawingml/2006/main" xmlns:r="http://schemas.openxmlformats.org/officeDocument/2006/relationships" xmlns:p="http://schemas.openxmlformats.org/presentationml/2006/main">
-  <p:cSld>
-    <p:bg>
-      <p:bgPr>
-        <a:solidFill>
-          <a:schemeClr val="bg1"/>
-        </a:solidFill>
-        <a:effectLst/>
-      </p:bgPr>
-    </p:bg>
-    <p:spTree>
-      <p:nvGrpSpPr>
-        <p:cNvPr id="1" name="">
-          <a:extLst>
-            <a:ext uri="{FF2B5EF4-FFF2-40B4-BE49-F238E27FC236}">
-              <a16:creationId xmlns:a16="http://schemas.microsoft.com/office/drawing/2014/main" id="{A0DC4AA3-0022-BA0D-9E7D-66B13B5B9A75}"/>
-            </a:ext>
-          </a:extLst>
-        </p:cNvPr>
-        <p:cNvGrpSpPr/>
-        <p:nvPr/>
-      </p:nvGrpSpPr>
-      <p:grpSpPr>
-        <a:xfrm>
-          <a:off x="0" y="0"/>
-          <a:ext cx="0" cy="0"/>
-          <a:chOff x="0" y="0"/>
-          <a:chExt cx="0" cy="0"/>
-        </a:xfrm>
-      </p:grpSpPr>
-      <p:sp>
-        <p:nvSpPr>
-          <p:cNvPr id="2" name="Rectangle 1">
-            <a:extLst>
-              <a:ext uri="{FF2B5EF4-FFF2-40B4-BE49-F238E27FC236}">
-                <a16:creationId xmlns:a16="http://schemas.microsoft.com/office/drawing/2014/main" id="{BB713812-7693-7A33-F95C-E7CBF82C0AC7}"/>
-              </a:ext>
-            </a:extLst>
-          </p:cNvPr>
-          <p:cNvSpPr/>
-          <p:nvPr/>
-        </p:nvSpPr>
-        <p:spPr>
-          <a:xfrm>
-            <a:off x="-795" y="25399"/>
-            <a:ext cx="10285413" cy="9144000"/>
-          </a:xfrm>
-          <a:prstGeom prst="rect">
-            <a:avLst/>
-          </a:prstGeom>
-          <a:gradFill flip="none" rotWithShape="1">
-            <a:gsLst>
-              <a:gs pos="0">
-                <a:srgbClr val="FF0000">
-                  <a:tint val="66000"/>
-                  <a:satMod val="160000"/>
-                </a:srgbClr>
-              </a:gs>
-              <a:gs pos="50000">
-                <a:srgbClr val="FF0000">
-                  <a:tint val="44500"/>
-                  <a:satMod val="160000"/>
-                </a:srgbClr>
-              </a:gs>
-              <a:gs pos="100000">
-                <a:srgbClr val="FF0000">
-                  <a:tint val="23500"/>
-                  <a:satMod val="160000"/>
-                </a:srgbClr>
-              </a:gs>
-            </a:gsLst>
-            <a:lin ang="13500000" scaled="1"/>
-            <a:tileRect/>
-          </a:gradFill>
-          <a:ln w="31750">
-            <a:solidFill>
-              <a:schemeClr val="accent1">
-                <a:shade val="15000"/>
-              </a:schemeClr>
-            </a:solidFill>
-          </a:ln>
-        </p:spPr>
-        <p:style>
-          <a:lnRef idx="2">
-            <a:schemeClr val="accent1">
-              <a:shade val="15000"/>
-            </a:schemeClr>
-          </a:lnRef>
-          <a:fillRef idx="1">
-            <a:schemeClr val="accent1"/>
-          </a:fillRef>
-          <a:effectRef idx="0">
-            <a:schemeClr val="accent1"/>
-          </a:effectRef>
-          <a:fontRef idx="minor">
-            <a:schemeClr val="lt1"/>
-          </a:fontRef>
-        </p:style>
-        <p:txBody>
-          <a:bodyPr rtlCol="0" anchor="ctr"/>
-          <a:lstStyle/>
-          <a:p>
-            <a:pPr marL="0" algn="ctr" defTabSz="457200" rtl="1" eaLnBrk="1" latinLnBrk="0" hangingPunct="1"/>
-            <a:endParaRPr lang="en-DE" dirty="0">
-              <a:latin typeface="Patrick Hand" pitchFamily="2" charset="77"/>
-            </a:endParaRPr>
-          </a:p>
-        </p:txBody>
-      </p:sp>
-      <p:sp>
-        <p:nvSpPr>
-          <p:cNvPr id="5" name="Rectangle 4">
-            <a:extLst>
-              <a:ext uri="{FF2B5EF4-FFF2-40B4-BE49-F238E27FC236}">
-                <a16:creationId xmlns:a16="http://schemas.microsoft.com/office/drawing/2014/main" id="{389978CD-953A-DE5A-0C5E-B22506EFEBA5}"/>
-              </a:ext>
-            </a:extLst>
-          </p:cNvPr>
-          <p:cNvSpPr/>
-          <p:nvPr/>
-        </p:nvSpPr>
-        <p:spPr>
-          <a:xfrm>
-            <a:off x="-794" y="9144000"/>
-            <a:ext cx="10285413" cy="9144000"/>
-          </a:xfrm>
-          <a:prstGeom prst="rect">
-            <a:avLst/>
-          </a:prstGeom>
-          <a:gradFill flip="none" rotWithShape="1">
-            <a:gsLst>
-              <a:gs pos="0">
-                <a:schemeClr val="accent6">
-                  <a:tint val="66000"/>
-                  <a:satMod val="160000"/>
-                </a:schemeClr>
-              </a:gs>
-              <a:gs pos="50000">
-                <a:schemeClr val="accent6">
-                  <a:tint val="44500"/>
-                  <a:satMod val="160000"/>
-                </a:schemeClr>
-              </a:gs>
-              <a:gs pos="100000">
-                <a:schemeClr val="accent6">
-                  <a:tint val="23500"/>
-                  <a:satMod val="160000"/>
-                </a:schemeClr>
-              </a:gs>
-            </a:gsLst>
-            <a:lin ang="13500000" scaled="1"/>
-            <a:tileRect/>
-          </a:gradFill>
-          <a:ln w="31750">
-            <a:solidFill>
-              <a:schemeClr val="accent1">
-                <a:shade val="15000"/>
-              </a:schemeClr>
-            </a:solidFill>
-          </a:ln>
-        </p:spPr>
-        <p:style>
-          <a:lnRef idx="2">
-            <a:schemeClr val="accent1">
-              <a:shade val="15000"/>
-            </a:schemeClr>
-          </a:lnRef>
-          <a:fillRef idx="1">
-            <a:schemeClr val="accent1"/>
-          </a:fillRef>
-          <a:effectRef idx="0">
-            <a:schemeClr val="accent1"/>
-          </a:effectRef>
-          <a:fontRef idx="minor">
-            <a:schemeClr val="lt1"/>
-          </a:fontRef>
-        </p:style>
-        <p:txBody>
-          <a:bodyPr rtlCol="0" anchor="ctr"/>
-          <a:lstStyle/>
-          <a:p>
-            <a:pPr marL="0" algn="ctr" defTabSz="457200" rtl="1" eaLnBrk="1" latinLnBrk="0" hangingPunct="1"/>
-            <a:endParaRPr lang="en-DE" dirty="0">
-              <a:latin typeface="Patrick Hand" pitchFamily="2" charset="77"/>
-            </a:endParaRPr>
-          </a:p>
-        </p:txBody>
-      </p:sp>
-      <p:pic>
-        <p:nvPicPr>
-          <p:cNvPr id="6" name="Picture 5">
-            <a:extLst>
-              <a:ext uri="{FF2B5EF4-FFF2-40B4-BE49-F238E27FC236}">
-                <a16:creationId xmlns:a16="http://schemas.microsoft.com/office/drawing/2014/main" id="{E9CF1C6B-B5DF-DB15-335C-9EF9D02E2644}"/>
-              </a:ext>
-            </a:extLst>
-          </p:cNvPr>
-          <p:cNvPicPr>
-            <a:picLocks noChangeAspect="1"/>
-          </p:cNvPicPr>
-          <p:nvPr/>
-        </p:nvPicPr>
-        <p:blipFill rotWithShape="1">
-          <a:blip r:embed="rId3"/>
-          <a:srcRect l="21500" t="36257" r="12564" b="17086"/>
-          <a:stretch>
-            <a:fillRect/>
-          </a:stretch>
-        </p:blipFill>
-        <p:spPr>
-          <a:xfrm>
-            <a:off x="9333" y="2819400"/>
-            <a:ext cx="10315977" cy="5486400"/>
-          </a:xfrm>
-          <a:prstGeom prst="rect">
-            <a:avLst/>
-          </a:prstGeom>
-        </p:spPr>
-      </p:pic>
-      <p:pic>
-        <p:nvPicPr>
-          <p:cNvPr id="7" name="Picture 6">
-            <a:extLst>
-              <a:ext uri="{FF2B5EF4-FFF2-40B4-BE49-F238E27FC236}">
-                <a16:creationId xmlns:a16="http://schemas.microsoft.com/office/drawing/2014/main" id="{F75C1FB9-F7E4-D807-6D39-929DB29A7EFE}"/>
-              </a:ext>
-            </a:extLst>
-          </p:cNvPr>
-          <p:cNvPicPr>
-            <a:picLocks noChangeAspect="1"/>
-          </p:cNvPicPr>
-          <p:nvPr/>
-        </p:nvPicPr>
-        <p:blipFill rotWithShape="1">
-          <a:blip r:embed="rId4"/>
-          <a:srcRect l="15971" t="42773" r="9579" b="22419"/>
-          <a:stretch>
-            <a:fillRect/>
-          </a:stretch>
-        </p:blipFill>
-        <p:spPr>
-          <a:xfrm>
-            <a:off x="-30564" y="12598400"/>
-            <a:ext cx="10305074" cy="2006600"/>
-          </a:xfrm>
-          <a:prstGeom prst="rect">
-            <a:avLst/>
-          </a:prstGeom>
-        </p:spPr>
-      </p:pic>
-      <p:sp>
-        <p:nvSpPr>
-          <p:cNvPr id="10" name="Rectangle 9">
-            <a:extLst>
-              <a:ext uri="{FF2B5EF4-FFF2-40B4-BE49-F238E27FC236}">
-                <a16:creationId xmlns:a16="http://schemas.microsoft.com/office/drawing/2014/main" id="{F931037C-127C-092B-3046-21C5E1305743}"/>
-              </a:ext>
-            </a:extLst>
-          </p:cNvPr>
-          <p:cNvSpPr/>
-          <p:nvPr/>
-        </p:nvSpPr>
-        <p:spPr>
-          <a:xfrm>
-            <a:off x="1577100" y="981670"/>
-            <a:ext cx="7131212" cy="1323439"/>
-          </a:xfrm>
-          <a:prstGeom prst="rect">
-            <a:avLst/>
-          </a:prstGeom>
-          <a:noFill/>
-          <a:ln>
-            <a:noFill/>
-          </a:ln>
-        </p:spPr>
-        <p:style>
-          <a:lnRef idx="0">
-            <a:scrgbClr r="0" g="0" b="0"/>
-          </a:lnRef>
-          <a:fillRef idx="0">
-            <a:scrgbClr r="0" g="0" b="0"/>
-          </a:fillRef>
-          <a:effectRef idx="0">
-            <a:scrgbClr r="0" g="0" b="0"/>
-          </a:effectRef>
-          <a:fontRef idx="minor">
-            <a:schemeClr val="accent6"/>
-          </a:fontRef>
-        </p:style>
-        <p:txBody>
-          <a:bodyPr wrap="square" lIns="91440" tIns="45720" rIns="91440" bIns="45720">
-            <a:spAutoFit/>
-          </a:bodyPr>
-          <a:lstStyle/>
-          <a:p>
-            <a:pPr algn="ctr"/>
-            <a:r>
-              <a:rPr lang="en-GB" sz="8000" b="1" dirty="0">
-                <a:ln w="6600">
-                  <a:solidFill>
-                    <a:schemeClr val="accent2"/>
-                  </a:solidFill>
-                  <a:prstDash val="solid"/>
-                </a:ln>
-                <a:solidFill>
-                  <a:srgbClr val="FFFFFF"/>
-                </a:solidFill>
-                <a:effectLst>
-                  <a:outerShdw dist="38100" dir="2700000" algn="tl" rotWithShape="0">
-                    <a:schemeClr val="accent2"/>
-                  </a:outerShdw>
-                </a:effectLst>
-                <a:latin typeface="Patrick Hand" pitchFamily="2" charset="77"/>
-              </a:rPr>
-              <a:t>DIRTY CODE</a:t>
-            </a:r>
-          </a:p>
-        </p:txBody>
-      </p:sp>
-      <p:pic>
-        <p:nvPicPr>
-          <p:cNvPr id="12" name="Graphic 11" descr="Close with solid fill">
-            <a:extLst>
-              <a:ext uri="{FF2B5EF4-FFF2-40B4-BE49-F238E27FC236}">
-                <a16:creationId xmlns:a16="http://schemas.microsoft.com/office/drawing/2014/main" id="{28F1D416-1464-F569-BAAC-4CE3AC639CD1}"/>
-              </a:ext>
-            </a:extLst>
-          </p:cNvPr>
-          <p:cNvPicPr>
-            <a:picLocks noChangeAspect="1"/>
-          </p:cNvPicPr>
-          <p:nvPr/>
-        </p:nvPicPr>
-        <p:blipFill>
-          <a:blip r:embed="rId5">
-            <a:extLst>
-              <a:ext uri="{96DAC541-7B7A-43D3-8B79-37D633B846F1}">
-                <asvg:svgBlip xmlns:asvg="http://schemas.microsoft.com/office/drawing/2016/SVG/main" r:embed="rId6"/>
-              </a:ext>
-            </a:extLst>
-          </a:blip>
-          <a:stretch>
-            <a:fillRect/>
-          </a:stretch>
-        </p:blipFill>
-        <p:spPr>
-          <a:xfrm>
-            <a:off x="7678818" y="1219200"/>
-            <a:ext cx="914400" cy="914400"/>
-          </a:xfrm>
-          <a:prstGeom prst="rect">
-            <a:avLst/>
-          </a:prstGeom>
-        </p:spPr>
-      </p:pic>
-      <p:pic>
-        <p:nvPicPr>
-          <p:cNvPr id="14" name="Graphic 13" descr="Tick with solid fill">
-            <a:extLst>
-              <a:ext uri="{FF2B5EF4-FFF2-40B4-BE49-F238E27FC236}">
-                <a16:creationId xmlns:a16="http://schemas.microsoft.com/office/drawing/2014/main" id="{F2663517-508C-9559-F50A-E9F1B59AB837}"/>
-              </a:ext>
-            </a:extLst>
-          </p:cNvPr>
-          <p:cNvPicPr>
-            <a:picLocks noChangeAspect="1"/>
-          </p:cNvPicPr>
-          <p:nvPr/>
-        </p:nvPicPr>
-        <p:blipFill>
-          <a:blip r:embed="rId7">
-            <a:extLst>
-              <a:ext uri="{96DAC541-7B7A-43D3-8B79-37D633B846F1}">
-                <asvg:svgBlip xmlns:asvg="http://schemas.microsoft.com/office/drawing/2016/SVG/main" r:embed="rId8"/>
-              </a:ext>
-            </a:extLst>
-          </a:blip>
-          <a:stretch>
-            <a:fillRect/>
-          </a:stretch>
-        </p:blipFill>
-        <p:spPr>
-          <a:xfrm>
-            <a:off x="7793912" y="10998200"/>
-            <a:ext cx="914400" cy="914400"/>
-          </a:xfrm>
-          <a:prstGeom prst="rect">
-            <a:avLst/>
-          </a:prstGeom>
-        </p:spPr>
-      </p:pic>
-      <p:sp>
-        <p:nvSpPr>
-          <p:cNvPr id="15" name="Rectangle 14">
-            <a:extLst>
-              <a:ext uri="{FF2B5EF4-FFF2-40B4-BE49-F238E27FC236}">
-                <a16:creationId xmlns:a16="http://schemas.microsoft.com/office/drawing/2014/main" id="{3C884966-F1E0-E28C-8306-94E3476AE9EB}"/>
-              </a:ext>
-            </a:extLst>
-          </p:cNvPr>
-          <p:cNvSpPr/>
-          <p:nvPr/>
-        </p:nvSpPr>
-        <p:spPr>
-          <a:xfrm>
-            <a:off x="1462006" y="10805060"/>
-            <a:ext cx="7131212" cy="1323439"/>
-          </a:xfrm>
-          <a:prstGeom prst="rect">
-            <a:avLst/>
-          </a:prstGeom>
-          <a:noFill/>
-          <a:ln>
-            <a:noFill/>
-          </a:ln>
-        </p:spPr>
-        <p:style>
-          <a:lnRef idx="0">
-            <a:scrgbClr r="0" g="0" b="0"/>
-          </a:lnRef>
-          <a:fillRef idx="0">
-            <a:scrgbClr r="0" g="0" b="0"/>
-          </a:fillRef>
-          <a:effectRef idx="0">
-            <a:scrgbClr r="0" g="0" b="0"/>
-          </a:effectRef>
-          <a:fontRef idx="minor">
-            <a:schemeClr val="accent6"/>
-          </a:fontRef>
-        </p:style>
-        <p:txBody>
-          <a:bodyPr wrap="square" lIns="91440" tIns="45720" rIns="91440" bIns="45720">
-            <a:spAutoFit/>
-          </a:bodyPr>
-          <a:lstStyle/>
-          <a:p>
-            <a:pPr algn="ctr"/>
-            <a:r>
-              <a:rPr lang="en-GB" sz="8000" b="1" dirty="0">
-                <a:ln w="12700">
-                  <a:solidFill>
-                    <a:srgbClr val="00B050"/>
-                  </a:solidFill>
-                  <a:prstDash val="solid"/>
-                </a:ln>
-                <a:pattFill prst="pct50">
-                  <a:fgClr>
-                    <a:schemeClr val="accent1"/>
-                  </a:fgClr>
-                  <a:bgClr>
-                    <a:schemeClr val="accent1">
-                      <a:lumMod val="20000"/>
-                      <a:lumOff val="80000"/>
-                    </a:schemeClr>
-                  </a:bgClr>
-                </a:pattFill>
-                <a:effectLst>
-                  <a:outerShdw dist="38100" dir="2640000" algn="bl" rotWithShape="0">
-                    <a:schemeClr val="accent1"/>
-                  </a:outerShdw>
-                </a:effectLst>
-                <a:latin typeface="Patrick Hand" pitchFamily="2" charset="77"/>
-              </a:rPr>
-              <a:t>CLEAN CODE</a:t>
-            </a:r>
-          </a:p>
-        </p:txBody>
-      </p:sp>
-      <p:sp>
-        <p:nvSpPr>
-          <p:cNvPr id="18" name="Down Arrow 17">
-            <a:extLst>
-              <a:ext uri="{FF2B5EF4-FFF2-40B4-BE49-F238E27FC236}">
-                <a16:creationId xmlns:a16="http://schemas.microsoft.com/office/drawing/2014/main" id="{F519B709-69F6-84B3-4A2B-206F2AAA7983}"/>
-              </a:ext>
-            </a:extLst>
-          </p:cNvPr>
-          <p:cNvSpPr/>
-          <p:nvPr/>
-        </p:nvSpPr>
-        <p:spPr>
-          <a:xfrm>
-            <a:off x="3683000" y="8610600"/>
-            <a:ext cx="2921000" cy="2194460"/>
-          </a:xfrm>
-          <a:prstGeom prst="downArrow">
-            <a:avLst/>
-          </a:prstGeom>
-          <a:solidFill>
-            <a:schemeClr val="bg1"/>
-          </a:solidFill>
-          <a:ln w="31750">
-            <a:solidFill>
-              <a:schemeClr val="accent1">
-                <a:shade val="15000"/>
-              </a:schemeClr>
-            </a:solidFill>
-          </a:ln>
-        </p:spPr>
-        <p:style>
-          <a:lnRef idx="2">
-            <a:schemeClr val="accent1">
-              <a:shade val="15000"/>
-            </a:schemeClr>
-          </a:lnRef>
-          <a:fillRef idx="1">
-            <a:schemeClr val="accent1"/>
-          </a:fillRef>
-          <a:effectRef idx="0">
-            <a:schemeClr val="accent1"/>
-          </a:effectRef>
-          <a:fontRef idx="minor">
-            <a:schemeClr val="lt1"/>
-          </a:fontRef>
-        </p:style>
-        <p:txBody>
-          <a:bodyPr rtlCol="0" anchor="ctr"/>
-          <a:lstStyle/>
-          <a:p>
-            <a:pPr marL="0" algn="ctr" defTabSz="457200" rtl="0" eaLnBrk="1" latinLnBrk="0" hangingPunct="1"/>
-            <a:endParaRPr lang="en-DE" dirty="0">
-              <a:latin typeface="Patrick Hand" pitchFamily="2" charset="77"/>
-            </a:endParaRPr>
-          </a:p>
-        </p:txBody>
-      </p:sp>
-      <p:sp>
-        <p:nvSpPr>
-          <p:cNvPr id="3" name="Rectangle 2">
-            <a:extLst>
-              <a:ext uri="{FF2B5EF4-FFF2-40B4-BE49-F238E27FC236}">
-                <a16:creationId xmlns:a16="http://schemas.microsoft.com/office/drawing/2014/main" id="{0A3573D3-02FD-8867-C498-4782AE7F0917}"/>
-              </a:ext>
-            </a:extLst>
-          </p:cNvPr>
-          <p:cNvSpPr/>
-          <p:nvPr/>
-        </p:nvSpPr>
-        <p:spPr>
-          <a:xfrm>
-            <a:off x="-8208470" y="2819400"/>
-            <a:ext cx="7768473" cy="923330"/>
-          </a:xfrm>
-          <a:prstGeom prst="rect">
-            <a:avLst/>
-          </a:prstGeom>
-          <a:ln>
-            <a:solidFill>
-              <a:schemeClr val="tx1"/>
-            </a:solidFill>
-          </a:ln>
-        </p:spPr>
-        <p:style>
-          <a:lnRef idx="1">
-            <a:schemeClr val="accent6"/>
-          </a:lnRef>
-          <a:fillRef idx="2">
-            <a:schemeClr val="accent6"/>
-          </a:fillRef>
-          <a:effectRef idx="1">
-            <a:schemeClr val="accent6"/>
-          </a:effectRef>
-          <a:fontRef idx="minor">
-            <a:schemeClr val="dk1"/>
-          </a:fontRef>
-        </p:style>
-        <p:txBody>
-          <a:bodyPr wrap="none" lIns="91440" tIns="45720" rIns="91440" bIns="45720">
-            <a:spAutoFit/>
-            <a:scene3d>
-              <a:camera prst="orthographicFront"/>
-              <a:lightRig rig="soft" dir="t">
-                <a:rot lat="0" lon="0" rev="15600000"/>
-              </a:lightRig>
-            </a:scene3d>
-            <a:sp3d extrusionH="57150" prstMaterial="softEdge">
-              <a:bevelT w="25400" h="38100"/>
-            </a:sp3d>
-          </a:bodyPr>
-          <a:lstStyle/>
-          <a:p>
-            <a:pPr algn="ctr"/>
-            <a:r>
-              <a:rPr lang="en-GB" sz="5400" dirty="0">
-                <a:ln w="0"/>
-                <a:solidFill>
-                  <a:schemeClr val="tx1"/>
-                </a:solidFill>
-                <a:effectLst>
-                  <a:outerShdw blurRad="38100" dist="19050" dir="2700000" algn="tl" rotWithShape="0">
-                    <a:schemeClr val="dk1">
-                      <a:alpha val="40000"/>
-                    </a:schemeClr>
-                  </a:outerShdw>
-                </a:effectLst>
-                <a:latin typeface="Patrick Hand" pitchFamily="2" charset="77"/>
-              </a:rPr>
-              <a:t>py_002_list_comprehensions</a:t>
-            </a:r>
-            <a:endParaRPr lang="en-DE" sz="5400" dirty="0">
-              <a:ln w="0"/>
-              <a:solidFill>
-                <a:schemeClr val="tx1"/>
-              </a:solidFill>
-              <a:effectLst>
-                <a:outerShdw blurRad="38100" dist="19050" dir="2700000" algn="tl" rotWithShape="0">
-                  <a:schemeClr val="dk1">
-                    <a:alpha val="40000"/>
-                  </a:schemeClr>
-                </a:outerShdw>
-              </a:effectLst>
-            </a:endParaRPr>
-          </a:p>
-        </p:txBody>
-      </p:sp>
-    </p:spTree>
-    <p:extLst>
-      <p:ext uri="{BB962C8B-B14F-4D97-AF65-F5344CB8AC3E}">
-        <p14:creationId xmlns:p14="http://schemas.microsoft.com/office/powerpoint/2010/main" val="1367177939"/>
-      </p:ext>
-    </p:extLst>
-  </p:cSld>
-  <p:clrMapOvr>
-    <a:masterClrMapping/>
-  </p:clrMapOvr>
-</p:sld>
-</file>
-
-<file path=ppt/slides/slide30.xml><?xml version="1.0" encoding="utf-8"?>
+<file path=ppt/slides/slide31.xml><?xml version="1.0" encoding="utf-8"?>
 <p:sld xmlns:a="http://schemas.openxmlformats.org/drawingml/2006/main" xmlns:r="http://schemas.openxmlformats.org/officeDocument/2006/relationships" xmlns:p="http://schemas.openxmlformats.org/presentationml/2006/main">
   <p:cSld>
     <p:bg>
@@ -16723,7 +17076,7 @@
 </p:sld>
 </file>
 
-<file path=ppt/slides/slide31.xml><?xml version="1.0" encoding="utf-8"?>
+<file path=ppt/slides/slide32.xml><?xml version="1.0" encoding="utf-8"?>
 <p:sld xmlns:a="http://schemas.openxmlformats.org/drawingml/2006/main" xmlns:r="http://schemas.openxmlformats.org/officeDocument/2006/relationships" xmlns:p="http://schemas.openxmlformats.org/presentationml/2006/main">
   <p:cSld>
     <p:bg>
@@ -17040,7 +17393,7 @@
 </p:sld>
 </file>
 
-<file path=ppt/slides/slide32.xml><?xml version="1.0" encoding="utf-8"?>
+<file path=ppt/slides/slide33.xml><?xml version="1.0" encoding="utf-8"?>
 <p:sld xmlns:a="http://schemas.openxmlformats.org/drawingml/2006/main" xmlns:r="http://schemas.openxmlformats.org/officeDocument/2006/relationships" xmlns:p="http://schemas.openxmlformats.org/presentationml/2006/main">
   <p:cSld>
     <p:bg>
@@ -17353,7 +17706,7 @@
 </p:sld>
 </file>
 
-<file path=ppt/slides/slide33.xml><?xml version="1.0" encoding="utf-8"?>
+<file path=ppt/slides/slide34.xml><?xml version="1.0" encoding="utf-8"?>
 <p:sld xmlns:a="http://schemas.openxmlformats.org/drawingml/2006/main" xmlns:r="http://schemas.openxmlformats.org/officeDocument/2006/relationships" xmlns:p="http://schemas.openxmlformats.org/presentationml/2006/main">
   <p:cSld>
     <p:bg>
@@ -17578,7 +17931,7 @@
 </p:sld>
 </file>
 
-<file path=ppt/slides/slide34.xml><?xml version="1.0" encoding="utf-8"?>
+<file path=ppt/slides/slide35.xml><?xml version="1.0" encoding="utf-8"?>
 <p:sld xmlns:a="http://schemas.openxmlformats.org/drawingml/2006/main" xmlns:r="http://schemas.openxmlformats.org/officeDocument/2006/relationships" xmlns:p="http://schemas.openxmlformats.org/presentationml/2006/main">
   <p:cSld>
     <p:bg>
@@ -17733,8 +18086,8 @@
         </p:nvSpPr>
         <p:spPr>
           <a:xfrm>
-            <a:off x="-7857400" y="2527667"/>
-            <a:ext cx="6524543" cy="830997"/>
+            <a:off x="-10475910" y="2463702"/>
+            <a:ext cx="8132354" cy="830997"/>
           </a:xfrm>
           <a:prstGeom prst="rect">
             <a:avLst/>
@@ -17742,13 +18095,13 @@
         </p:spPr>
         <p:style>
           <a:lnRef idx="1">
-            <a:schemeClr val="accent2"/>
+            <a:schemeClr val="accent6"/>
           </a:lnRef>
           <a:fillRef idx="2">
-            <a:schemeClr val="accent2"/>
+            <a:schemeClr val="accent6"/>
           </a:fillRef>
           <a:effectRef idx="1">
-            <a:schemeClr val="accent2"/>
+            <a:schemeClr val="accent6"/>
           </a:effectRef>
           <a:fontRef idx="minor">
             <a:schemeClr val="dk1"/>
@@ -17762,17 +18115,33 @@
           <a:p>
             <a:r>
               <a:rPr lang="en-US" sz="4800" dirty="0">
+                <a:ln w="0"/>
                 <a:solidFill>
-                  <a:srgbClr val="FF0000"/>
+                  <a:schemeClr val="tx1"/>
                 </a:solidFill>
+                <a:effectLst>
+                  <a:outerShdw blurRad="38100" dist="19050" dir="2700000" algn="tl" rotWithShape="0">
+                    <a:schemeClr val="dk1">
+                      <a:alpha val="40000"/>
+                    </a:schemeClr>
+                  </a:outerShdw>
+                </a:effectLst>
                 <a:latin typeface="Patrick Hand" pitchFamily="2" charset="77"/>
               </a:rPr>
-              <a:t>vitest_001_test_your_code</a:t>
+              <a:t>Image: vitest_001_test_your_code</a:t>
             </a:r>
             <a:endParaRPr lang="en-DE" sz="4800" dirty="0">
+              <a:ln w="0"/>
               <a:solidFill>
-                <a:srgbClr val="FF0000"/>
+                <a:schemeClr val="tx1"/>
               </a:solidFill>
+              <a:effectLst>
+                <a:outerShdw blurRad="38100" dist="19050" dir="2700000" algn="tl" rotWithShape="0">
+                  <a:schemeClr val="dk1">
+                    <a:alpha val="40000"/>
+                  </a:schemeClr>
+                </a:outerShdw>
+              </a:effectLst>
               <a:latin typeface="Patrick Hand" pitchFamily="2" charset="77"/>
             </a:endParaRPr>
           </a:p>
@@ -17907,7 +18276,7 @@
 </p:sld>
 </file>
 
-<file path=ppt/slides/slide35.xml><?xml version="1.0" encoding="utf-8"?>
+<file path=ppt/slides/slide36.xml><?xml version="1.0" encoding="utf-8"?>
 <p:sld xmlns:a="http://schemas.openxmlformats.org/drawingml/2006/main" xmlns:r="http://schemas.openxmlformats.org/officeDocument/2006/relationships" xmlns:p="http://schemas.openxmlformats.org/presentationml/2006/main">
   <p:cSld>
     <p:spTree>

</xml_diff>